<commit_message>
Add deployment caching and external API documentation
</commit_message>
<xml_diff>
--- a/design/workspace.pptx
+++ b/design/workspace.pptx
@@ -8,6 +8,7 @@
     <p:sldId id="256" r:id="rId2"/>
     <p:sldId id="258" r:id="rId3"/>
     <p:sldId id="257" r:id="rId4"/>
+    <p:sldId id="259" r:id="rId5"/>
   </p:sldIdLst>
   <p:sldSz cx="12192000" cy="6858000"/>
   <p:notesSz cx="6858000" cy="9144000"/>
@@ -106,6 +107,11 @@
       </a:defRPr>
     </a:lvl9pPr>
   </p:defaultTextStyle>
+  <p:extLst>
+    <p:ext uri="{EFAFB233-063F-42B5-8137-9DF3F51BA10A}">
+      <p15:sldGuideLst xmlns:p15="http://schemas.microsoft.com/office/powerpoint/2012/main"/>
+    </p:ext>
+  </p:extLst>
 </p:presentation>
 </file>
 
@@ -240,7 +246,7 @@
           <a:p>
             <a:fld id="{B090EF8C-6A08-40E1-AA1D-27EAD8C7E042}" type="datetimeFigureOut">
               <a:rPr lang="en-IN" smtClean="0"/>
-              <a:t>24-07-2026</a:t>
+              <a:t>26-07-2026</a:t>
             </a:fld>
             <a:endParaRPr lang="en-IN"/>
           </a:p>
@@ -410,7 +416,7 @@
           <a:p>
             <a:fld id="{B090EF8C-6A08-40E1-AA1D-27EAD8C7E042}" type="datetimeFigureOut">
               <a:rPr lang="en-IN" smtClean="0"/>
-              <a:t>24-07-2026</a:t>
+              <a:t>26-07-2026</a:t>
             </a:fld>
             <a:endParaRPr lang="en-IN"/>
           </a:p>
@@ -590,7 +596,7 @@
           <a:p>
             <a:fld id="{B090EF8C-6A08-40E1-AA1D-27EAD8C7E042}" type="datetimeFigureOut">
               <a:rPr lang="en-IN" smtClean="0"/>
-              <a:t>24-07-2026</a:t>
+              <a:t>26-07-2026</a:t>
             </a:fld>
             <a:endParaRPr lang="en-IN"/>
           </a:p>
@@ -760,7 +766,7 @@
           <a:p>
             <a:fld id="{B090EF8C-6A08-40E1-AA1D-27EAD8C7E042}" type="datetimeFigureOut">
               <a:rPr lang="en-IN" smtClean="0"/>
-              <a:t>24-07-2026</a:t>
+              <a:t>26-07-2026</a:t>
             </a:fld>
             <a:endParaRPr lang="en-IN"/>
           </a:p>
@@ -1006,7 +1012,7 @@
           <a:p>
             <a:fld id="{B090EF8C-6A08-40E1-AA1D-27EAD8C7E042}" type="datetimeFigureOut">
               <a:rPr lang="en-IN" smtClean="0"/>
-              <a:t>24-07-2026</a:t>
+              <a:t>26-07-2026</a:t>
             </a:fld>
             <a:endParaRPr lang="en-IN"/>
           </a:p>
@@ -1238,7 +1244,7 @@
           <a:p>
             <a:fld id="{B090EF8C-6A08-40E1-AA1D-27EAD8C7E042}" type="datetimeFigureOut">
               <a:rPr lang="en-IN" smtClean="0"/>
-              <a:t>24-07-2026</a:t>
+              <a:t>26-07-2026</a:t>
             </a:fld>
             <a:endParaRPr lang="en-IN"/>
           </a:p>
@@ -1605,7 +1611,7 @@
           <a:p>
             <a:fld id="{B090EF8C-6A08-40E1-AA1D-27EAD8C7E042}" type="datetimeFigureOut">
               <a:rPr lang="en-IN" smtClean="0"/>
-              <a:t>24-07-2026</a:t>
+              <a:t>26-07-2026</a:t>
             </a:fld>
             <a:endParaRPr lang="en-IN"/>
           </a:p>
@@ -1723,7 +1729,7 @@
           <a:p>
             <a:fld id="{B090EF8C-6A08-40E1-AA1D-27EAD8C7E042}" type="datetimeFigureOut">
               <a:rPr lang="en-IN" smtClean="0"/>
-              <a:t>24-07-2026</a:t>
+              <a:t>26-07-2026</a:t>
             </a:fld>
             <a:endParaRPr lang="en-IN"/>
           </a:p>
@@ -1818,7 +1824,7 @@
           <a:p>
             <a:fld id="{B090EF8C-6A08-40E1-AA1D-27EAD8C7E042}" type="datetimeFigureOut">
               <a:rPr lang="en-IN" smtClean="0"/>
-              <a:t>24-07-2026</a:t>
+              <a:t>26-07-2026</a:t>
             </a:fld>
             <a:endParaRPr lang="en-IN"/>
           </a:p>
@@ -2095,7 +2101,7 @@
           <a:p>
             <a:fld id="{B090EF8C-6A08-40E1-AA1D-27EAD8C7E042}" type="datetimeFigureOut">
               <a:rPr lang="en-IN" smtClean="0"/>
-              <a:t>24-07-2026</a:t>
+              <a:t>26-07-2026</a:t>
             </a:fld>
             <a:endParaRPr lang="en-IN"/>
           </a:p>
@@ -2348,7 +2354,7 @@
           <a:p>
             <a:fld id="{B090EF8C-6A08-40E1-AA1D-27EAD8C7E042}" type="datetimeFigureOut">
               <a:rPr lang="en-IN" smtClean="0"/>
-              <a:t>24-07-2026</a:t>
+              <a:t>26-07-2026</a:t>
             </a:fld>
             <a:endParaRPr lang="en-IN"/>
           </a:p>
@@ -2561,7 +2567,7 @@
           <a:p>
             <a:fld id="{B090EF8C-6A08-40E1-AA1D-27EAD8C7E042}" type="datetimeFigureOut">
               <a:rPr lang="en-IN" smtClean="0"/>
-              <a:t>24-07-2026</a:t>
+              <a:t>26-07-2026</a:t>
             </a:fld>
             <a:endParaRPr lang="en-IN"/>
           </a:p>
@@ -9166,6 +9172,91 @@
 </p:sld>
 </file>
 
+<file path=ppt/slides/slide4.xml><?xml version="1.0" encoding="utf-8"?>
+<p:sld xmlns:a="http://schemas.openxmlformats.org/drawingml/2006/main" xmlns:r="http://schemas.openxmlformats.org/officeDocument/2006/relationships" xmlns:p="http://schemas.openxmlformats.org/presentationml/2006/main">
+  <p:cSld>
+    <p:spTree>
+      <p:nvGrpSpPr>
+        <p:cNvPr id="1" name=""/>
+        <p:cNvGrpSpPr/>
+        <p:nvPr/>
+      </p:nvGrpSpPr>
+      <p:grpSpPr>
+        <a:xfrm>
+          <a:off x="0" y="0"/>
+          <a:ext cx="0" cy="0"/>
+          <a:chOff x="0" y="0"/>
+          <a:chExt cx="0" cy="0"/>
+        </a:xfrm>
+      </p:grpSpPr>
+      <p:pic>
+        <p:nvPicPr>
+          <p:cNvPr id="2" name="Picture 1"/>
+          <p:cNvPicPr>
+            <a:picLocks noChangeAspect="1"/>
+          </p:cNvPicPr>
+          <p:nvPr/>
+        </p:nvPicPr>
+        <p:blipFill rotWithShape="1">
+          <a:blip r:embed="rId2">
+            <a:extLst>
+              <a:ext uri="{BEBA8EAE-BF5A-486C-A8C5-ECC9F3942E4B}">
+                <a14:imgProps xmlns:a14="http://schemas.microsoft.com/office/drawing/2010/main">
+                  <a14:imgLayer r:embed="rId3">
+                    <a14:imgEffect>
+                      <a14:backgroundRemoval t="2637" b="89941" l="8301" r="89941">
+                        <a14:foregroundMark x1="59277" y1="45898" x2="59277" y2="45898"/>
+                        <a14:foregroundMark x1="67188" y1="53906" x2="67188" y2="53906"/>
+                        <a14:foregroundMark x1="60156" y1="38477" x2="53320" y2="54785"/>
+                        <a14:foregroundMark x1="46094" y1="17383" x2="34863" y2="67773"/>
+                        <a14:foregroundMark x1="25879" y1="43359" x2="46875" y2="64648"/>
+                        <a14:foregroundMark x1="36621" y1="36133" x2="54980" y2="68555"/>
+                        <a14:foregroundMark x1="27246" y1="41992" x2="52637" y2="47559"/>
+                        <a14:foregroundMark x1="51465" y1="40723" x2="39063" y2="40723"/>
+                        <a14:foregroundMark x1="68750" y1="22363" x2="70410" y2="27734"/>
+                        <a14:foregroundMark x1="71875" y1="18164" x2="55176" y2="43164"/>
+                        <a14:foregroundMark x1="66895" y1="20703" x2="71875" y2="41895"/>
+                        <a14:foregroundMark x1="73340" y1="21680" x2="71680" y2="34863"/>
+                        <a14:foregroundMark x1="70508" y1="21484" x2="73535" y2="33691"/>
+                        <a14:foregroundMark x1="41895" y1="18164" x2="41895" y2="18164"/>
+                        <a14:foregroundMark x1="40527" y1="58887" x2="43848" y2="74414"/>
+                        <a14:foregroundMark x1="41309" y1="52441" x2="44824" y2="58496"/>
+                      </a14:backgroundRemoval>
+                    </a14:imgEffect>
+                  </a14:imgLayer>
+                </a14:imgProps>
+              </a:ext>
+              <a:ext uri="{28A0092B-C50C-407E-A947-70E740481C1C}">
+                <a14:useLocalDpi xmlns:a14="http://schemas.microsoft.com/office/drawing/2010/main" val="0"/>
+              </a:ext>
+            </a:extLst>
+          </a:blip>
+          <a:srcRect l="15555" t="2778" r="13889" b="11389"/>
+          <a:stretch/>
+        </p:blipFill>
+        <p:spPr>
+          <a:xfrm>
+            <a:off x="3733800" y="190500"/>
+            <a:ext cx="4838700" cy="5886450"/>
+          </a:xfrm>
+          <a:prstGeom prst="rect">
+            <a:avLst/>
+          </a:prstGeom>
+        </p:spPr>
+      </p:pic>
+    </p:spTree>
+    <p:extLst>
+      <p:ext uri="{BB962C8B-B14F-4D97-AF65-F5344CB8AC3E}">
+        <p14:creationId xmlns:p14="http://schemas.microsoft.com/office/powerpoint/2010/main" val="3883432461"/>
+      </p:ext>
+    </p:extLst>
+  </p:cSld>
+  <p:clrMapOvr>
+    <a:masterClrMapping/>
+  </p:clrMapOvr>
+</p:sld>
+</file>
+
 <file path=ppt/theme/theme1.xml><?xml version="1.0" encoding="utf-8"?>
 <a:theme xmlns:a="http://schemas.openxmlformats.org/drawingml/2006/main" name="Office Theme">
   <a:themeElements>

</xml_diff>

<commit_message>
Add Brevo email provider and portal updates
</commit_message>
<xml_diff>
--- a/design/workspace.pptx
+++ b/design/workspace.pptx
@@ -9,6 +9,7 @@
     <p:sldId id="258" r:id="rId3"/>
     <p:sldId id="257" r:id="rId4"/>
     <p:sldId id="259" r:id="rId5"/>
+    <p:sldId id="260" r:id="rId6"/>
   </p:sldIdLst>
   <p:sldSz cx="12192000" cy="6858000"/>
   <p:notesSz cx="6858000" cy="9144000"/>
@@ -246,7 +247,7 @@
           <a:p>
             <a:fld id="{B090EF8C-6A08-40E1-AA1D-27EAD8C7E042}" type="datetimeFigureOut">
               <a:rPr lang="en-IN" smtClean="0"/>
-              <a:t>26-07-2026</a:t>
+              <a:t>30-07-2026</a:t>
             </a:fld>
             <a:endParaRPr lang="en-IN"/>
           </a:p>
@@ -416,7 +417,7 @@
           <a:p>
             <a:fld id="{B090EF8C-6A08-40E1-AA1D-27EAD8C7E042}" type="datetimeFigureOut">
               <a:rPr lang="en-IN" smtClean="0"/>
-              <a:t>26-07-2026</a:t>
+              <a:t>30-07-2026</a:t>
             </a:fld>
             <a:endParaRPr lang="en-IN"/>
           </a:p>
@@ -596,7 +597,7 @@
           <a:p>
             <a:fld id="{B090EF8C-6A08-40E1-AA1D-27EAD8C7E042}" type="datetimeFigureOut">
               <a:rPr lang="en-IN" smtClean="0"/>
-              <a:t>26-07-2026</a:t>
+              <a:t>30-07-2026</a:t>
             </a:fld>
             <a:endParaRPr lang="en-IN"/>
           </a:p>
@@ -766,7 +767,7 @@
           <a:p>
             <a:fld id="{B090EF8C-6A08-40E1-AA1D-27EAD8C7E042}" type="datetimeFigureOut">
               <a:rPr lang="en-IN" smtClean="0"/>
-              <a:t>26-07-2026</a:t>
+              <a:t>30-07-2026</a:t>
             </a:fld>
             <a:endParaRPr lang="en-IN"/>
           </a:p>
@@ -1012,7 +1013,7 @@
           <a:p>
             <a:fld id="{B090EF8C-6A08-40E1-AA1D-27EAD8C7E042}" type="datetimeFigureOut">
               <a:rPr lang="en-IN" smtClean="0"/>
-              <a:t>26-07-2026</a:t>
+              <a:t>30-07-2026</a:t>
             </a:fld>
             <a:endParaRPr lang="en-IN"/>
           </a:p>
@@ -1244,7 +1245,7 @@
           <a:p>
             <a:fld id="{B090EF8C-6A08-40E1-AA1D-27EAD8C7E042}" type="datetimeFigureOut">
               <a:rPr lang="en-IN" smtClean="0"/>
-              <a:t>26-07-2026</a:t>
+              <a:t>30-07-2026</a:t>
             </a:fld>
             <a:endParaRPr lang="en-IN"/>
           </a:p>
@@ -1611,7 +1612,7 @@
           <a:p>
             <a:fld id="{B090EF8C-6A08-40E1-AA1D-27EAD8C7E042}" type="datetimeFigureOut">
               <a:rPr lang="en-IN" smtClean="0"/>
-              <a:t>26-07-2026</a:t>
+              <a:t>30-07-2026</a:t>
             </a:fld>
             <a:endParaRPr lang="en-IN"/>
           </a:p>
@@ -1729,7 +1730,7 @@
           <a:p>
             <a:fld id="{B090EF8C-6A08-40E1-AA1D-27EAD8C7E042}" type="datetimeFigureOut">
               <a:rPr lang="en-IN" smtClean="0"/>
-              <a:t>26-07-2026</a:t>
+              <a:t>30-07-2026</a:t>
             </a:fld>
             <a:endParaRPr lang="en-IN"/>
           </a:p>
@@ -1824,7 +1825,7 @@
           <a:p>
             <a:fld id="{B090EF8C-6A08-40E1-AA1D-27EAD8C7E042}" type="datetimeFigureOut">
               <a:rPr lang="en-IN" smtClean="0"/>
-              <a:t>26-07-2026</a:t>
+              <a:t>30-07-2026</a:t>
             </a:fld>
             <a:endParaRPr lang="en-IN"/>
           </a:p>
@@ -2101,7 +2102,7 @@
           <a:p>
             <a:fld id="{B090EF8C-6A08-40E1-AA1D-27EAD8C7E042}" type="datetimeFigureOut">
               <a:rPr lang="en-IN" smtClean="0"/>
-              <a:t>26-07-2026</a:t>
+              <a:t>30-07-2026</a:t>
             </a:fld>
             <a:endParaRPr lang="en-IN"/>
           </a:p>
@@ -2354,7 +2355,7 @@
           <a:p>
             <a:fld id="{B090EF8C-6A08-40E1-AA1D-27EAD8C7E042}" type="datetimeFigureOut">
               <a:rPr lang="en-IN" smtClean="0"/>
-              <a:t>26-07-2026</a:t>
+              <a:t>30-07-2026</a:t>
             </a:fld>
             <a:endParaRPr lang="en-IN"/>
           </a:p>
@@ -2567,7 +2568,7 @@
           <a:p>
             <a:fld id="{B090EF8C-6A08-40E1-AA1D-27EAD8C7E042}" type="datetimeFigureOut">
               <a:rPr lang="en-IN" smtClean="0"/>
-              <a:t>26-07-2026</a:t>
+              <a:t>30-07-2026</a:t>
             </a:fld>
             <a:endParaRPr lang="en-IN"/>
           </a:p>
@@ -9257,6 +9258,613 @@
 </p:sld>
 </file>
 
+<file path=ppt/slides/slide5.xml><?xml version="1.0" encoding="utf-8"?>
+<p:sld xmlns:a="http://schemas.openxmlformats.org/drawingml/2006/main" xmlns:r="http://schemas.openxmlformats.org/officeDocument/2006/relationships" xmlns:p="http://schemas.openxmlformats.org/presentationml/2006/main">
+  <p:cSld>
+    <p:spTree>
+      <p:nvGrpSpPr>
+        <p:cNvPr id="1" name=""/>
+        <p:cNvGrpSpPr/>
+        <p:nvPr/>
+      </p:nvGrpSpPr>
+      <p:grpSpPr>
+        <a:xfrm>
+          <a:off x="0" y="0"/>
+          <a:ext cx="0" cy="0"/>
+          <a:chOff x="0" y="0"/>
+          <a:chExt cx="0" cy="0"/>
+        </a:xfrm>
+      </p:grpSpPr>
+      <p:grpSp>
+        <p:nvGrpSpPr>
+          <p:cNvPr id="14" name="Group 13"/>
+          <p:cNvGrpSpPr/>
+          <p:nvPr/>
+        </p:nvGrpSpPr>
+        <p:grpSpPr>
+          <a:xfrm>
+            <a:off x="660400" y="482600"/>
+            <a:ext cx="8115300" cy="3268365"/>
+            <a:chOff x="660400" y="482600"/>
+            <a:chExt cx="8115300" cy="3268365"/>
+          </a:xfrm>
+        </p:grpSpPr>
+        <p:grpSp>
+          <p:nvGrpSpPr>
+            <p:cNvPr id="12" name="Group 11"/>
+            <p:cNvGrpSpPr/>
+            <p:nvPr/>
+          </p:nvGrpSpPr>
+          <p:grpSpPr>
+            <a:xfrm>
+              <a:off x="660400" y="482600"/>
+              <a:ext cx="8115300" cy="2806700"/>
+              <a:chOff x="660400" y="482600"/>
+              <a:chExt cx="8115300" cy="2806700"/>
+            </a:xfrm>
+          </p:grpSpPr>
+          <p:sp>
+            <p:nvSpPr>
+              <p:cNvPr id="2" name="Rectangle 1"/>
+              <p:cNvSpPr/>
+              <p:nvPr/>
+            </p:nvSpPr>
+            <p:spPr>
+              <a:xfrm>
+                <a:off x="660400" y="482600"/>
+                <a:ext cx="901700" cy="2806700"/>
+              </a:xfrm>
+              <a:prstGeom prst="rect">
+                <a:avLst/>
+              </a:prstGeom>
+              <a:solidFill>
+                <a:schemeClr val="accent6">
+                  <a:lumMod val="20000"/>
+                  <a:lumOff val="80000"/>
+                </a:schemeClr>
+              </a:solidFill>
+              <a:ln>
+                <a:noFill/>
+              </a:ln>
+            </p:spPr>
+            <p:style>
+              <a:lnRef idx="2">
+                <a:schemeClr val="accent1">
+                  <a:shade val="50000"/>
+                </a:schemeClr>
+              </a:lnRef>
+              <a:fillRef idx="1">
+                <a:schemeClr val="accent1"/>
+              </a:fillRef>
+              <a:effectRef idx="0">
+                <a:schemeClr val="accent1"/>
+              </a:effectRef>
+              <a:fontRef idx="minor">
+                <a:schemeClr val="lt1"/>
+              </a:fontRef>
+            </p:style>
+            <p:txBody>
+              <a:bodyPr vert="vert270" rtlCol="0" anchor="ctr"/>
+              <a:lstStyle/>
+              <a:p>
+                <a:pPr algn="ctr"/>
+                <a:r>
+                  <a:rPr lang="en-US" sz="2000" dirty="0" smtClean="0">
+                    <a:solidFill>
+                      <a:schemeClr val="tx1"/>
+                    </a:solidFill>
+                    <a:latin typeface="Arial Rounded MT Bold" panose="020F0704030504030204" pitchFamily="34" charset="0"/>
+                  </a:rPr>
+                  <a:t>226,240,217</a:t>
+                </a:r>
+                <a:endParaRPr lang="en-IN" sz="2000" dirty="0">
+                  <a:solidFill>
+                    <a:schemeClr val="tx1"/>
+                  </a:solidFill>
+                  <a:latin typeface="Arial Rounded MT Bold" panose="020F0704030504030204" pitchFamily="34" charset="0"/>
+                </a:endParaRPr>
+              </a:p>
+            </p:txBody>
+          </p:sp>
+          <p:sp>
+            <p:nvSpPr>
+              <p:cNvPr id="3" name="Rectangle 2"/>
+              <p:cNvSpPr/>
+              <p:nvPr/>
+            </p:nvSpPr>
+            <p:spPr>
+              <a:xfrm>
+                <a:off x="1562100" y="482600"/>
+                <a:ext cx="901700" cy="2806700"/>
+              </a:xfrm>
+              <a:prstGeom prst="rect">
+                <a:avLst/>
+              </a:prstGeom>
+              <a:solidFill>
+                <a:schemeClr val="accent6">
+                  <a:lumMod val="40000"/>
+                  <a:lumOff val="60000"/>
+                </a:schemeClr>
+              </a:solidFill>
+              <a:ln>
+                <a:noFill/>
+              </a:ln>
+            </p:spPr>
+            <p:style>
+              <a:lnRef idx="2">
+                <a:schemeClr val="accent1">
+                  <a:shade val="50000"/>
+                </a:schemeClr>
+              </a:lnRef>
+              <a:fillRef idx="1">
+                <a:schemeClr val="accent1"/>
+              </a:fillRef>
+              <a:effectRef idx="0">
+                <a:schemeClr val="accent1"/>
+              </a:effectRef>
+              <a:fontRef idx="minor">
+                <a:schemeClr val="lt1"/>
+              </a:fontRef>
+            </p:style>
+            <p:txBody>
+              <a:bodyPr rtlCol="0" anchor="ctr"/>
+              <a:lstStyle/>
+              <a:p>
+                <a:pPr algn="ctr"/>
+                <a:endParaRPr lang="en-IN"/>
+              </a:p>
+            </p:txBody>
+          </p:sp>
+          <p:sp>
+            <p:nvSpPr>
+              <p:cNvPr id="4" name="Rectangle 3"/>
+              <p:cNvSpPr/>
+              <p:nvPr/>
+            </p:nvSpPr>
+            <p:spPr>
+              <a:xfrm>
+                <a:off x="4267200" y="482600"/>
+                <a:ext cx="901700" cy="2806700"/>
+              </a:xfrm>
+              <a:prstGeom prst="rect">
+                <a:avLst/>
+              </a:prstGeom>
+              <a:solidFill>
+                <a:srgbClr val="87BF61"/>
+              </a:solidFill>
+              <a:ln>
+                <a:noFill/>
+              </a:ln>
+            </p:spPr>
+            <p:style>
+              <a:lnRef idx="2">
+                <a:schemeClr val="accent1">
+                  <a:shade val="50000"/>
+                </a:schemeClr>
+              </a:lnRef>
+              <a:fillRef idx="1">
+                <a:schemeClr val="accent1"/>
+              </a:fillRef>
+              <a:effectRef idx="0">
+                <a:schemeClr val="accent1"/>
+              </a:effectRef>
+              <a:fontRef idx="minor">
+                <a:schemeClr val="lt1"/>
+              </a:fontRef>
+            </p:style>
+            <p:txBody>
+              <a:bodyPr rtlCol="0" anchor="ctr"/>
+              <a:lstStyle/>
+              <a:p>
+                <a:pPr algn="ctr"/>
+                <a:endParaRPr lang="en-IN"/>
+              </a:p>
+            </p:txBody>
+          </p:sp>
+          <p:sp>
+            <p:nvSpPr>
+              <p:cNvPr id="5" name="Rectangle 4"/>
+              <p:cNvSpPr/>
+              <p:nvPr/>
+            </p:nvSpPr>
+            <p:spPr>
+              <a:xfrm>
+                <a:off x="2463800" y="482600"/>
+                <a:ext cx="901700" cy="2806700"/>
+              </a:xfrm>
+              <a:prstGeom prst="rect">
+                <a:avLst/>
+              </a:prstGeom>
+              <a:solidFill>
+                <a:schemeClr val="accent6">
+                  <a:lumMod val="60000"/>
+                  <a:lumOff val="40000"/>
+                </a:schemeClr>
+              </a:solidFill>
+              <a:ln>
+                <a:noFill/>
+              </a:ln>
+            </p:spPr>
+            <p:style>
+              <a:lnRef idx="2">
+                <a:schemeClr val="accent1">
+                  <a:shade val="50000"/>
+                </a:schemeClr>
+              </a:lnRef>
+              <a:fillRef idx="1">
+                <a:schemeClr val="accent1"/>
+              </a:fillRef>
+              <a:effectRef idx="0">
+                <a:schemeClr val="accent1"/>
+              </a:effectRef>
+              <a:fontRef idx="minor">
+                <a:schemeClr val="lt1"/>
+              </a:fontRef>
+            </p:style>
+            <p:txBody>
+              <a:bodyPr rtlCol="0" anchor="ctr"/>
+              <a:lstStyle/>
+              <a:p>
+                <a:pPr algn="ctr"/>
+                <a:endParaRPr lang="en-IN"/>
+              </a:p>
+            </p:txBody>
+          </p:sp>
+          <p:sp>
+            <p:nvSpPr>
+              <p:cNvPr id="6" name="Rectangle 5"/>
+              <p:cNvSpPr/>
+              <p:nvPr/>
+            </p:nvSpPr>
+            <p:spPr>
+              <a:xfrm>
+                <a:off x="6070600" y="482600"/>
+                <a:ext cx="901700" cy="2806700"/>
+              </a:xfrm>
+              <a:prstGeom prst="rect">
+                <a:avLst/>
+              </a:prstGeom>
+              <a:solidFill>
+                <a:schemeClr val="accent6"/>
+              </a:solidFill>
+              <a:ln>
+                <a:noFill/>
+              </a:ln>
+            </p:spPr>
+            <p:style>
+              <a:lnRef idx="2">
+                <a:schemeClr val="accent1">
+                  <a:shade val="50000"/>
+                </a:schemeClr>
+              </a:lnRef>
+              <a:fillRef idx="1">
+                <a:schemeClr val="accent1"/>
+              </a:fillRef>
+              <a:effectRef idx="0">
+                <a:schemeClr val="accent1"/>
+              </a:effectRef>
+              <a:fontRef idx="minor">
+                <a:schemeClr val="lt1"/>
+              </a:fontRef>
+            </p:style>
+            <p:txBody>
+              <a:bodyPr rtlCol="0" anchor="ctr"/>
+              <a:lstStyle/>
+              <a:p>
+                <a:pPr algn="ctr"/>
+                <a:endParaRPr lang="en-IN"/>
+              </a:p>
+            </p:txBody>
+          </p:sp>
+          <p:sp>
+            <p:nvSpPr>
+              <p:cNvPr id="7" name="Rectangle 6"/>
+              <p:cNvSpPr/>
+              <p:nvPr/>
+            </p:nvSpPr>
+            <p:spPr>
+              <a:xfrm>
+                <a:off x="6972300" y="482600"/>
+                <a:ext cx="901700" cy="2806700"/>
+              </a:xfrm>
+              <a:prstGeom prst="rect">
+                <a:avLst/>
+              </a:prstGeom>
+              <a:solidFill>
+                <a:schemeClr val="accent6">
+                  <a:lumMod val="75000"/>
+                </a:schemeClr>
+              </a:solidFill>
+              <a:ln>
+                <a:noFill/>
+              </a:ln>
+            </p:spPr>
+            <p:style>
+              <a:lnRef idx="2">
+                <a:schemeClr val="accent1">
+                  <a:shade val="50000"/>
+                </a:schemeClr>
+              </a:lnRef>
+              <a:fillRef idx="1">
+                <a:schemeClr val="accent1"/>
+              </a:fillRef>
+              <a:effectRef idx="0">
+                <a:schemeClr val="accent1"/>
+              </a:effectRef>
+              <a:fontRef idx="minor">
+                <a:schemeClr val="lt1"/>
+              </a:fontRef>
+            </p:style>
+            <p:txBody>
+              <a:bodyPr rtlCol="0" anchor="ctr"/>
+              <a:lstStyle/>
+              <a:p>
+                <a:pPr algn="ctr"/>
+                <a:endParaRPr lang="en-IN"/>
+              </a:p>
+            </p:txBody>
+          </p:sp>
+          <p:sp>
+            <p:nvSpPr>
+              <p:cNvPr id="8" name="Rectangle 7"/>
+              <p:cNvSpPr/>
+              <p:nvPr/>
+            </p:nvSpPr>
+            <p:spPr>
+              <a:xfrm>
+                <a:off x="7874000" y="482600"/>
+                <a:ext cx="901700" cy="2806700"/>
+              </a:xfrm>
+              <a:prstGeom prst="rect">
+                <a:avLst/>
+              </a:prstGeom>
+              <a:solidFill>
+                <a:schemeClr val="accent6">
+                  <a:lumMod val="50000"/>
+                </a:schemeClr>
+              </a:solidFill>
+              <a:ln>
+                <a:noFill/>
+              </a:ln>
+            </p:spPr>
+            <p:style>
+              <a:lnRef idx="2">
+                <a:schemeClr val="accent1">
+                  <a:shade val="50000"/>
+                </a:schemeClr>
+              </a:lnRef>
+              <a:fillRef idx="1">
+                <a:schemeClr val="accent1"/>
+              </a:fillRef>
+              <a:effectRef idx="0">
+                <a:schemeClr val="accent1"/>
+              </a:effectRef>
+              <a:fontRef idx="minor">
+                <a:schemeClr val="lt1"/>
+              </a:fontRef>
+            </p:style>
+            <p:txBody>
+              <a:bodyPr rtlCol="0" anchor="ctr"/>
+              <a:lstStyle/>
+              <a:p>
+                <a:pPr algn="ctr"/>
+                <a:endParaRPr lang="en-IN"/>
+              </a:p>
+            </p:txBody>
+          </p:sp>
+          <p:sp>
+            <p:nvSpPr>
+              <p:cNvPr id="10" name="Rectangle 9"/>
+              <p:cNvSpPr/>
+              <p:nvPr/>
+            </p:nvSpPr>
+            <p:spPr>
+              <a:xfrm>
+                <a:off x="3365500" y="482600"/>
+                <a:ext cx="901700" cy="2806700"/>
+              </a:xfrm>
+              <a:prstGeom prst="rect">
+                <a:avLst/>
+              </a:prstGeom>
+              <a:solidFill>
+                <a:srgbClr val="91C46E"/>
+              </a:solidFill>
+              <a:ln>
+                <a:noFill/>
+              </a:ln>
+            </p:spPr>
+            <p:style>
+              <a:lnRef idx="2">
+                <a:schemeClr val="accent1">
+                  <a:shade val="50000"/>
+                </a:schemeClr>
+              </a:lnRef>
+              <a:fillRef idx="1">
+                <a:schemeClr val="accent1"/>
+              </a:fillRef>
+              <a:effectRef idx="0">
+                <a:schemeClr val="accent1"/>
+              </a:effectRef>
+              <a:fontRef idx="minor">
+                <a:schemeClr val="lt1"/>
+              </a:fontRef>
+            </p:style>
+            <p:txBody>
+              <a:bodyPr rtlCol="0" anchor="ctr"/>
+              <a:lstStyle/>
+              <a:p>
+                <a:pPr algn="ctr"/>
+                <a:endParaRPr lang="en-IN"/>
+              </a:p>
+            </p:txBody>
+          </p:sp>
+          <p:sp>
+            <p:nvSpPr>
+              <p:cNvPr id="11" name="Rectangle 10"/>
+              <p:cNvSpPr/>
+              <p:nvPr/>
+            </p:nvSpPr>
+            <p:spPr>
+              <a:xfrm>
+                <a:off x="5168900" y="482600"/>
+                <a:ext cx="901700" cy="2806700"/>
+              </a:xfrm>
+              <a:prstGeom prst="rect">
+                <a:avLst/>
+              </a:prstGeom>
+              <a:solidFill>
+                <a:srgbClr val="7CB953"/>
+              </a:solidFill>
+              <a:ln>
+                <a:noFill/>
+              </a:ln>
+            </p:spPr>
+            <p:style>
+              <a:lnRef idx="2">
+                <a:schemeClr val="accent1">
+                  <a:shade val="50000"/>
+                </a:schemeClr>
+              </a:lnRef>
+              <a:fillRef idx="1">
+                <a:schemeClr val="accent1"/>
+              </a:fillRef>
+              <a:effectRef idx="0">
+                <a:schemeClr val="accent1"/>
+              </a:effectRef>
+              <a:fontRef idx="minor">
+                <a:schemeClr val="lt1"/>
+              </a:fontRef>
+            </p:style>
+            <p:txBody>
+              <a:bodyPr rtlCol="0" anchor="ctr"/>
+              <a:lstStyle/>
+              <a:p>
+                <a:pPr algn="ctr"/>
+                <a:endParaRPr lang="en-IN"/>
+              </a:p>
+            </p:txBody>
+          </p:sp>
+        </p:grpSp>
+        <p:sp>
+          <p:nvSpPr>
+            <p:cNvPr id="13" name="TextBox 12"/>
+            <p:cNvSpPr txBox="1"/>
+            <p:nvPr/>
+          </p:nvSpPr>
+          <p:spPr>
+            <a:xfrm>
+              <a:off x="807364" y="3289300"/>
+              <a:ext cx="7821372" cy="461665"/>
+            </a:xfrm>
+            <a:prstGeom prst="rect">
+              <a:avLst/>
+            </a:prstGeom>
+            <a:noFill/>
+          </p:spPr>
+          <p:txBody>
+            <a:bodyPr wrap="none" rtlCol="0">
+              <a:spAutoFit/>
+            </a:bodyPr>
+            <a:lstStyle/>
+            <a:p>
+              <a:r>
+                <a:rPr lang="en-US" sz="2400" dirty="0" smtClean="0">
+                  <a:latin typeface="Arial Rounded MT Bold" panose="020F0704030504030204" pitchFamily="34" charset="0"/>
+                </a:rPr>
+                <a:t>A1      A2       A3 </a:t>
+              </a:r>
+              <a:r>
+                <a:rPr lang="en-US" sz="2400" dirty="0">
+                  <a:latin typeface="Arial Rounded MT Bold" panose="020F0704030504030204" pitchFamily="34" charset="0"/>
+                </a:rPr>
+                <a:t> </a:t>
+              </a:r>
+              <a:r>
+                <a:rPr lang="en-US" sz="2400" dirty="0" smtClean="0">
+                  <a:latin typeface="Arial Rounded MT Bold" panose="020F0704030504030204" pitchFamily="34" charset="0"/>
+                </a:rPr>
+                <a:t>    A4 </a:t>
+              </a:r>
+              <a:r>
+                <a:rPr lang="en-US" sz="2400" dirty="0">
+                  <a:latin typeface="Arial Rounded MT Bold" panose="020F0704030504030204" pitchFamily="34" charset="0"/>
+                </a:rPr>
+                <a:t> </a:t>
+              </a:r>
+              <a:r>
+                <a:rPr lang="en-US" sz="2400" dirty="0" smtClean="0">
+                  <a:latin typeface="Arial Rounded MT Bold" panose="020F0704030504030204" pitchFamily="34" charset="0"/>
+                </a:rPr>
+                <a:t>     A5 </a:t>
+              </a:r>
+              <a:r>
+                <a:rPr lang="en-US" sz="2400" dirty="0">
+                  <a:latin typeface="Arial Rounded MT Bold" panose="020F0704030504030204" pitchFamily="34" charset="0"/>
+                </a:rPr>
+                <a:t> </a:t>
+              </a:r>
+              <a:r>
+                <a:rPr lang="en-US" sz="2400" dirty="0" smtClean="0">
+                  <a:latin typeface="Arial Rounded MT Bold" panose="020F0704030504030204" pitchFamily="34" charset="0"/>
+                </a:rPr>
+                <a:t>    A6 </a:t>
+              </a:r>
+              <a:r>
+                <a:rPr lang="en-US" sz="2400" dirty="0">
+                  <a:latin typeface="Arial Rounded MT Bold" panose="020F0704030504030204" pitchFamily="34" charset="0"/>
+                </a:rPr>
+                <a:t> </a:t>
+              </a:r>
+              <a:r>
+                <a:rPr lang="en-US" sz="2400" dirty="0" smtClean="0">
+                  <a:latin typeface="Arial Rounded MT Bold" panose="020F0704030504030204" pitchFamily="34" charset="0"/>
+                </a:rPr>
+                <a:t>     A7 </a:t>
+              </a:r>
+              <a:r>
+                <a:rPr lang="en-US" sz="2400" dirty="0">
+                  <a:latin typeface="Arial Rounded MT Bold" panose="020F0704030504030204" pitchFamily="34" charset="0"/>
+                </a:rPr>
+                <a:t> </a:t>
+              </a:r>
+              <a:r>
+                <a:rPr lang="en-US" sz="2400" dirty="0" smtClean="0">
+                  <a:latin typeface="Arial Rounded MT Bold" panose="020F0704030504030204" pitchFamily="34" charset="0"/>
+                </a:rPr>
+                <a:t>    A8 </a:t>
+              </a:r>
+              <a:r>
+                <a:rPr lang="en-US" sz="2400" dirty="0">
+                  <a:latin typeface="Arial Rounded MT Bold" panose="020F0704030504030204" pitchFamily="34" charset="0"/>
+                </a:rPr>
+                <a:t> </a:t>
+              </a:r>
+              <a:r>
+                <a:rPr lang="en-US" sz="2400" dirty="0" smtClean="0">
+                  <a:latin typeface="Arial Rounded MT Bold" panose="020F0704030504030204" pitchFamily="34" charset="0"/>
+                </a:rPr>
+                <a:t>     A9</a:t>
+              </a:r>
+              <a:endParaRPr lang="en-IN" sz="2400" dirty="0">
+                <a:latin typeface="Arial Rounded MT Bold" panose="020F0704030504030204" pitchFamily="34" charset="0"/>
+              </a:endParaRPr>
+            </a:p>
+          </p:txBody>
+        </p:sp>
+      </p:grpSp>
+    </p:spTree>
+    <p:extLst>
+      <p:ext uri="{BB962C8B-B14F-4D97-AF65-F5344CB8AC3E}">
+        <p14:creationId xmlns:p14="http://schemas.microsoft.com/office/powerpoint/2010/main" val="586146957"/>
+      </p:ext>
+    </p:extLst>
+  </p:cSld>
+  <p:clrMapOvr>
+    <a:masterClrMapping/>
+  </p:clrMapOvr>
+</p:sld>
+</file>
+
 <file path=ppt/theme/theme1.xml><?xml version="1.0" encoding="utf-8"?>
 <a:theme xmlns:a="http://schemas.openxmlformats.org/drawingml/2006/main" name="Office Theme">
   <a:themeElements>

</xml_diff>

<commit_message>
Update Smart Sportz tournament flows
</commit_message>
<xml_diff>
--- a/design/workspace.pptx
+++ b/design/workspace.pptx
@@ -8,6 +8,8 @@
     <p:sldId id="256" r:id="rId2"/>
     <p:sldId id="258" r:id="rId3"/>
     <p:sldId id="257" r:id="rId4"/>
+    <p:sldId id="259" r:id="rId5"/>
+    <p:sldId id="260" r:id="rId6"/>
   </p:sldIdLst>
   <p:sldSz cx="12192000" cy="6858000"/>
   <p:notesSz cx="6858000" cy="9144000"/>
@@ -106,6 +108,11 @@
       </a:defRPr>
     </a:lvl9pPr>
   </p:defaultTextStyle>
+  <p:extLst>
+    <p:ext uri="{EFAFB233-063F-42B5-8137-9DF3F51BA10A}">
+      <p15:sldGuideLst xmlns:p15="http://schemas.microsoft.com/office/powerpoint/2012/main"/>
+    </p:ext>
+  </p:extLst>
 </p:presentation>
 </file>
 
@@ -240,7 +247,7 @@
           <a:p>
             <a:fld id="{B090EF8C-6A08-40E1-AA1D-27EAD8C7E042}" type="datetimeFigureOut">
               <a:rPr lang="en-IN" smtClean="0"/>
-              <a:t>24-07-2026</a:t>
+              <a:t>30-07-2026</a:t>
             </a:fld>
             <a:endParaRPr lang="en-IN"/>
           </a:p>
@@ -410,7 +417,7 @@
           <a:p>
             <a:fld id="{B090EF8C-6A08-40E1-AA1D-27EAD8C7E042}" type="datetimeFigureOut">
               <a:rPr lang="en-IN" smtClean="0"/>
-              <a:t>24-07-2026</a:t>
+              <a:t>30-07-2026</a:t>
             </a:fld>
             <a:endParaRPr lang="en-IN"/>
           </a:p>
@@ -590,7 +597,7 @@
           <a:p>
             <a:fld id="{B090EF8C-6A08-40E1-AA1D-27EAD8C7E042}" type="datetimeFigureOut">
               <a:rPr lang="en-IN" smtClean="0"/>
-              <a:t>24-07-2026</a:t>
+              <a:t>30-07-2026</a:t>
             </a:fld>
             <a:endParaRPr lang="en-IN"/>
           </a:p>
@@ -760,7 +767,7 @@
           <a:p>
             <a:fld id="{B090EF8C-6A08-40E1-AA1D-27EAD8C7E042}" type="datetimeFigureOut">
               <a:rPr lang="en-IN" smtClean="0"/>
-              <a:t>24-07-2026</a:t>
+              <a:t>30-07-2026</a:t>
             </a:fld>
             <a:endParaRPr lang="en-IN"/>
           </a:p>
@@ -1006,7 +1013,7 @@
           <a:p>
             <a:fld id="{B090EF8C-6A08-40E1-AA1D-27EAD8C7E042}" type="datetimeFigureOut">
               <a:rPr lang="en-IN" smtClean="0"/>
-              <a:t>24-07-2026</a:t>
+              <a:t>30-07-2026</a:t>
             </a:fld>
             <a:endParaRPr lang="en-IN"/>
           </a:p>
@@ -1238,7 +1245,7 @@
           <a:p>
             <a:fld id="{B090EF8C-6A08-40E1-AA1D-27EAD8C7E042}" type="datetimeFigureOut">
               <a:rPr lang="en-IN" smtClean="0"/>
-              <a:t>24-07-2026</a:t>
+              <a:t>30-07-2026</a:t>
             </a:fld>
             <a:endParaRPr lang="en-IN"/>
           </a:p>
@@ -1605,7 +1612,7 @@
           <a:p>
             <a:fld id="{B090EF8C-6A08-40E1-AA1D-27EAD8C7E042}" type="datetimeFigureOut">
               <a:rPr lang="en-IN" smtClean="0"/>
-              <a:t>24-07-2026</a:t>
+              <a:t>30-07-2026</a:t>
             </a:fld>
             <a:endParaRPr lang="en-IN"/>
           </a:p>
@@ -1723,7 +1730,7 @@
           <a:p>
             <a:fld id="{B090EF8C-6A08-40E1-AA1D-27EAD8C7E042}" type="datetimeFigureOut">
               <a:rPr lang="en-IN" smtClean="0"/>
-              <a:t>24-07-2026</a:t>
+              <a:t>30-07-2026</a:t>
             </a:fld>
             <a:endParaRPr lang="en-IN"/>
           </a:p>
@@ -1818,7 +1825,7 @@
           <a:p>
             <a:fld id="{B090EF8C-6A08-40E1-AA1D-27EAD8C7E042}" type="datetimeFigureOut">
               <a:rPr lang="en-IN" smtClean="0"/>
-              <a:t>24-07-2026</a:t>
+              <a:t>30-07-2026</a:t>
             </a:fld>
             <a:endParaRPr lang="en-IN"/>
           </a:p>
@@ -2095,7 +2102,7 @@
           <a:p>
             <a:fld id="{B090EF8C-6A08-40E1-AA1D-27EAD8C7E042}" type="datetimeFigureOut">
               <a:rPr lang="en-IN" smtClean="0"/>
-              <a:t>24-07-2026</a:t>
+              <a:t>30-07-2026</a:t>
             </a:fld>
             <a:endParaRPr lang="en-IN"/>
           </a:p>
@@ -2348,7 +2355,7 @@
           <a:p>
             <a:fld id="{B090EF8C-6A08-40E1-AA1D-27EAD8C7E042}" type="datetimeFigureOut">
               <a:rPr lang="en-IN" smtClean="0"/>
-              <a:t>24-07-2026</a:t>
+              <a:t>30-07-2026</a:t>
             </a:fld>
             <a:endParaRPr lang="en-IN"/>
           </a:p>
@@ -2561,7 +2568,7 @@
           <a:p>
             <a:fld id="{B090EF8C-6A08-40E1-AA1D-27EAD8C7E042}" type="datetimeFigureOut">
               <a:rPr lang="en-IN" smtClean="0"/>
-              <a:t>24-07-2026</a:t>
+              <a:t>30-07-2026</a:t>
             </a:fld>
             <a:endParaRPr lang="en-IN"/>
           </a:p>
@@ -9166,6 +9173,698 @@
 </p:sld>
 </file>
 
+<file path=ppt/slides/slide4.xml><?xml version="1.0" encoding="utf-8"?>
+<p:sld xmlns:a="http://schemas.openxmlformats.org/drawingml/2006/main" xmlns:r="http://schemas.openxmlformats.org/officeDocument/2006/relationships" xmlns:p="http://schemas.openxmlformats.org/presentationml/2006/main">
+  <p:cSld>
+    <p:spTree>
+      <p:nvGrpSpPr>
+        <p:cNvPr id="1" name=""/>
+        <p:cNvGrpSpPr/>
+        <p:nvPr/>
+      </p:nvGrpSpPr>
+      <p:grpSpPr>
+        <a:xfrm>
+          <a:off x="0" y="0"/>
+          <a:ext cx="0" cy="0"/>
+          <a:chOff x="0" y="0"/>
+          <a:chExt cx="0" cy="0"/>
+        </a:xfrm>
+      </p:grpSpPr>
+      <p:pic>
+        <p:nvPicPr>
+          <p:cNvPr id="2" name="Picture 1"/>
+          <p:cNvPicPr>
+            <a:picLocks noChangeAspect="1"/>
+          </p:cNvPicPr>
+          <p:nvPr/>
+        </p:nvPicPr>
+        <p:blipFill rotWithShape="1">
+          <a:blip r:embed="rId2">
+            <a:extLst>
+              <a:ext uri="{BEBA8EAE-BF5A-486C-A8C5-ECC9F3942E4B}">
+                <a14:imgProps xmlns:a14="http://schemas.microsoft.com/office/drawing/2010/main">
+                  <a14:imgLayer r:embed="rId3">
+                    <a14:imgEffect>
+                      <a14:backgroundRemoval t="2637" b="89941" l="8301" r="89941">
+                        <a14:foregroundMark x1="59277" y1="45898" x2="59277" y2="45898"/>
+                        <a14:foregroundMark x1="67188" y1="53906" x2="67188" y2="53906"/>
+                        <a14:foregroundMark x1="60156" y1="38477" x2="53320" y2="54785"/>
+                        <a14:foregroundMark x1="46094" y1="17383" x2="34863" y2="67773"/>
+                        <a14:foregroundMark x1="25879" y1="43359" x2="46875" y2="64648"/>
+                        <a14:foregroundMark x1="36621" y1="36133" x2="54980" y2="68555"/>
+                        <a14:foregroundMark x1="27246" y1="41992" x2="52637" y2="47559"/>
+                        <a14:foregroundMark x1="51465" y1="40723" x2="39063" y2="40723"/>
+                        <a14:foregroundMark x1="68750" y1="22363" x2="70410" y2="27734"/>
+                        <a14:foregroundMark x1="71875" y1="18164" x2="55176" y2="43164"/>
+                        <a14:foregroundMark x1="66895" y1="20703" x2="71875" y2="41895"/>
+                        <a14:foregroundMark x1="73340" y1="21680" x2="71680" y2="34863"/>
+                        <a14:foregroundMark x1="70508" y1="21484" x2="73535" y2="33691"/>
+                        <a14:foregroundMark x1="41895" y1="18164" x2="41895" y2="18164"/>
+                        <a14:foregroundMark x1="40527" y1="58887" x2="43848" y2="74414"/>
+                        <a14:foregroundMark x1="41309" y1="52441" x2="44824" y2="58496"/>
+                      </a14:backgroundRemoval>
+                    </a14:imgEffect>
+                  </a14:imgLayer>
+                </a14:imgProps>
+              </a:ext>
+              <a:ext uri="{28A0092B-C50C-407E-A947-70E740481C1C}">
+                <a14:useLocalDpi xmlns:a14="http://schemas.microsoft.com/office/drawing/2010/main" val="0"/>
+              </a:ext>
+            </a:extLst>
+          </a:blip>
+          <a:srcRect l="15555" t="2778" r="13889" b="11389"/>
+          <a:stretch/>
+        </p:blipFill>
+        <p:spPr>
+          <a:xfrm>
+            <a:off x="3733800" y="190500"/>
+            <a:ext cx="4838700" cy="5886450"/>
+          </a:xfrm>
+          <a:prstGeom prst="rect">
+            <a:avLst/>
+          </a:prstGeom>
+        </p:spPr>
+      </p:pic>
+    </p:spTree>
+    <p:extLst>
+      <p:ext uri="{BB962C8B-B14F-4D97-AF65-F5344CB8AC3E}">
+        <p14:creationId xmlns:p14="http://schemas.microsoft.com/office/powerpoint/2010/main" val="3883432461"/>
+      </p:ext>
+    </p:extLst>
+  </p:cSld>
+  <p:clrMapOvr>
+    <a:masterClrMapping/>
+  </p:clrMapOvr>
+</p:sld>
+</file>
+
+<file path=ppt/slides/slide5.xml><?xml version="1.0" encoding="utf-8"?>
+<p:sld xmlns:a="http://schemas.openxmlformats.org/drawingml/2006/main" xmlns:r="http://schemas.openxmlformats.org/officeDocument/2006/relationships" xmlns:p="http://schemas.openxmlformats.org/presentationml/2006/main">
+  <p:cSld>
+    <p:spTree>
+      <p:nvGrpSpPr>
+        <p:cNvPr id="1" name=""/>
+        <p:cNvGrpSpPr/>
+        <p:nvPr/>
+      </p:nvGrpSpPr>
+      <p:grpSpPr>
+        <a:xfrm>
+          <a:off x="0" y="0"/>
+          <a:ext cx="0" cy="0"/>
+          <a:chOff x="0" y="0"/>
+          <a:chExt cx="0" cy="0"/>
+        </a:xfrm>
+      </p:grpSpPr>
+      <p:grpSp>
+        <p:nvGrpSpPr>
+          <p:cNvPr id="14" name="Group 13"/>
+          <p:cNvGrpSpPr/>
+          <p:nvPr/>
+        </p:nvGrpSpPr>
+        <p:grpSpPr>
+          <a:xfrm>
+            <a:off x="660400" y="482600"/>
+            <a:ext cx="8115300" cy="3268365"/>
+            <a:chOff x="660400" y="482600"/>
+            <a:chExt cx="8115300" cy="3268365"/>
+          </a:xfrm>
+        </p:grpSpPr>
+        <p:grpSp>
+          <p:nvGrpSpPr>
+            <p:cNvPr id="12" name="Group 11"/>
+            <p:cNvGrpSpPr/>
+            <p:nvPr/>
+          </p:nvGrpSpPr>
+          <p:grpSpPr>
+            <a:xfrm>
+              <a:off x="660400" y="482600"/>
+              <a:ext cx="8115300" cy="2806700"/>
+              <a:chOff x="660400" y="482600"/>
+              <a:chExt cx="8115300" cy="2806700"/>
+            </a:xfrm>
+          </p:grpSpPr>
+          <p:sp>
+            <p:nvSpPr>
+              <p:cNvPr id="2" name="Rectangle 1"/>
+              <p:cNvSpPr/>
+              <p:nvPr/>
+            </p:nvSpPr>
+            <p:spPr>
+              <a:xfrm>
+                <a:off x="660400" y="482600"/>
+                <a:ext cx="901700" cy="2806700"/>
+              </a:xfrm>
+              <a:prstGeom prst="rect">
+                <a:avLst/>
+              </a:prstGeom>
+              <a:solidFill>
+                <a:schemeClr val="accent6">
+                  <a:lumMod val="20000"/>
+                  <a:lumOff val="80000"/>
+                </a:schemeClr>
+              </a:solidFill>
+              <a:ln>
+                <a:noFill/>
+              </a:ln>
+            </p:spPr>
+            <p:style>
+              <a:lnRef idx="2">
+                <a:schemeClr val="accent1">
+                  <a:shade val="50000"/>
+                </a:schemeClr>
+              </a:lnRef>
+              <a:fillRef idx="1">
+                <a:schemeClr val="accent1"/>
+              </a:fillRef>
+              <a:effectRef idx="0">
+                <a:schemeClr val="accent1"/>
+              </a:effectRef>
+              <a:fontRef idx="minor">
+                <a:schemeClr val="lt1"/>
+              </a:fontRef>
+            </p:style>
+            <p:txBody>
+              <a:bodyPr vert="vert270" rtlCol="0" anchor="ctr"/>
+              <a:lstStyle/>
+              <a:p>
+                <a:pPr algn="ctr"/>
+                <a:r>
+                  <a:rPr lang="en-US" sz="2000" dirty="0" smtClean="0">
+                    <a:solidFill>
+                      <a:schemeClr val="tx1"/>
+                    </a:solidFill>
+                    <a:latin typeface="Arial Rounded MT Bold" panose="020F0704030504030204" pitchFamily="34" charset="0"/>
+                  </a:rPr>
+                  <a:t>226,240,217</a:t>
+                </a:r>
+                <a:endParaRPr lang="en-IN" sz="2000" dirty="0">
+                  <a:solidFill>
+                    <a:schemeClr val="tx1"/>
+                  </a:solidFill>
+                  <a:latin typeface="Arial Rounded MT Bold" panose="020F0704030504030204" pitchFamily="34" charset="0"/>
+                </a:endParaRPr>
+              </a:p>
+            </p:txBody>
+          </p:sp>
+          <p:sp>
+            <p:nvSpPr>
+              <p:cNvPr id="3" name="Rectangle 2"/>
+              <p:cNvSpPr/>
+              <p:nvPr/>
+            </p:nvSpPr>
+            <p:spPr>
+              <a:xfrm>
+                <a:off x="1562100" y="482600"/>
+                <a:ext cx="901700" cy="2806700"/>
+              </a:xfrm>
+              <a:prstGeom prst="rect">
+                <a:avLst/>
+              </a:prstGeom>
+              <a:solidFill>
+                <a:schemeClr val="accent6">
+                  <a:lumMod val="40000"/>
+                  <a:lumOff val="60000"/>
+                </a:schemeClr>
+              </a:solidFill>
+              <a:ln>
+                <a:noFill/>
+              </a:ln>
+            </p:spPr>
+            <p:style>
+              <a:lnRef idx="2">
+                <a:schemeClr val="accent1">
+                  <a:shade val="50000"/>
+                </a:schemeClr>
+              </a:lnRef>
+              <a:fillRef idx="1">
+                <a:schemeClr val="accent1"/>
+              </a:fillRef>
+              <a:effectRef idx="0">
+                <a:schemeClr val="accent1"/>
+              </a:effectRef>
+              <a:fontRef idx="minor">
+                <a:schemeClr val="lt1"/>
+              </a:fontRef>
+            </p:style>
+            <p:txBody>
+              <a:bodyPr rtlCol="0" anchor="ctr"/>
+              <a:lstStyle/>
+              <a:p>
+                <a:pPr algn="ctr"/>
+                <a:endParaRPr lang="en-IN"/>
+              </a:p>
+            </p:txBody>
+          </p:sp>
+          <p:sp>
+            <p:nvSpPr>
+              <p:cNvPr id="4" name="Rectangle 3"/>
+              <p:cNvSpPr/>
+              <p:nvPr/>
+            </p:nvSpPr>
+            <p:spPr>
+              <a:xfrm>
+                <a:off x="4267200" y="482600"/>
+                <a:ext cx="901700" cy="2806700"/>
+              </a:xfrm>
+              <a:prstGeom prst="rect">
+                <a:avLst/>
+              </a:prstGeom>
+              <a:solidFill>
+                <a:srgbClr val="87BF61"/>
+              </a:solidFill>
+              <a:ln>
+                <a:noFill/>
+              </a:ln>
+            </p:spPr>
+            <p:style>
+              <a:lnRef idx="2">
+                <a:schemeClr val="accent1">
+                  <a:shade val="50000"/>
+                </a:schemeClr>
+              </a:lnRef>
+              <a:fillRef idx="1">
+                <a:schemeClr val="accent1"/>
+              </a:fillRef>
+              <a:effectRef idx="0">
+                <a:schemeClr val="accent1"/>
+              </a:effectRef>
+              <a:fontRef idx="minor">
+                <a:schemeClr val="lt1"/>
+              </a:fontRef>
+            </p:style>
+            <p:txBody>
+              <a:bodyPr rtlCol="0" anchor="ctr"/>
+              <a:lstStyle/>
+              <a:p>
+                <a:pPr algn="ctr"/>
+                <a:endParaRPr lang="en-IN"/>
+              </a:p>
+            </p:txBody>
+          </p:sp>
+          <p:sp>
+            <p:nvSpPr>
+              <p:cNvPr id="5" name="Rectangle 4"/>
+              <p:cNvSpPr/>
+              <p:nvPr/>
+            </p:nvSpPr>
+            <p:spPr>
+              <a:xfrm>
+                <a:off x="2463800" y="482600"/>
+                <a:ext cx="901700" cy="2806700"/>
+              </a:xfrm>
+              <a:prstGeom prst="rect">
+                <a:avLst/>
+              </a:prstGeom>
+              <a:solidFill>
+                <a:schemeClr val="accent6">
+                  <a:lumMod val="60000"/>
+                  <a:lumOff val="40000"/>
+                </a:schemeClr>
+              </a:solidFill>
+              <a:ln>
+                <a:noFill/>
+              </a:ln>
+            </p:spPr>
+            <p:style>
+              <a:lnRef idx="2">
+                <a:schemeClr val="accent1">
+                  <a:shade val="50000"/>
+                </a:schemeClr>
+              </a:lnRef>
+              <a:fillRef idx="1">
+                <a:schemeClr val="accent1"/>
+              </a:fillRef>
+              <a:effectRef idx="0">
+                <a:schemeClr val="accent1"/>
+              </a:effectRef>
+              <a:fontRef idx="minor">
+                <a:schemeClr val="lt1"/>
+              </a:fontRef>
+            </p:style>
+            <p:txBody>
+              <a:bodyPr rtlCol="0" anchor="ctr"/>
+              <a:lstStyle/>
+              <a:p>
+                <a:pPr algn="ctr"/>
+                <a:endParaRPr lang="en-IN"/>
+              </a:p>
+            </p:txBody>
+          </p:sp>
+          <p:sp>
+            <p:nvSpPr>
+              <p:cNvPr id="6" name="Rectangle 5"/>
+              <p:cNvSpPr/>
+              <p:nvPr/>
+            </p:nvSpPr>
+            <p:spPr>
+              <a:xfrm>
+                <a:off x="6070600" y="482600"/>
+                <a:ext cx="901700" cy="2806700"/>
+              </a:xfrm>
+              <a:prstGeom prst="rect">
+                <a:avLst/>
+              </a:prstGeom>
+              <a:solidFill>
+                <a:schemeClr val="accent6"/>
+              </a:solidFill>
+              <a:ln>
+                <a:noFill/>
+              </a:ln>
+            </p:spPr>
+            <p:style>
+              <a:lnRef idx="2">
+                <a:schemeClr val="accent1">
+                  <a:shade val="50000"/>
+                </a:schemeClr>
+              </a:lnRef>
+              <a:fillRef idx="1">
+                <a:schemeClr val="accent1"/>
+              </a:fillRef>
+              <a:effectRef idx="0">
+                <a:schemeClr val="accent1"/>
+              </a:effectRef>
+              <a:fontRef idx="minor">
+                <a:schemeClr val="lt1"/>
+              </a:fontRef>
+            </p:style>
+            <p:txBody>
+              <a:bodyPr rtlCol="0" anchor="ctr"/>
+              <a:lstStyle/>
+              <a:p>
+                <a:pPr algn="ctr"/>
+                <a:endParaRPr lang="en-IN"/>
+              </a:p>
+            </p:txBody>
+          </p:sp>
+          <p:sp>
+            <p:nvSpPr>
+              <p:cNvPr id="7" name="Rectangle 6"/>
+              <p:cNvSpPr/>
+              <p:nvPr/>
+            </p:nvSpPr>
+            <p:spPr>
+              <a:xfrm>
+                <a:off x="6972300" y="482600"/>
+                <a:ext cx="901700" cy="2806700"/>
+              </a:xfrm>
+              <a:prstGeom prst="rect">
+                <a:avLst/>
+              </a:prstGeom>
+              <a:solidFill>
+                <a:schemeClr val="accent6">
+                  <a:lumMod val="75000"/>
+                </a:schemeClr>
+              </a:solidFill>
+              <a:ln>
+                <a:noFill/>
+              </a:ln>
+            </p:spPr>
+            <p:style>
+              <a:lnRef idx="2">
+                <a:schemeClr val="accent1">
+                  <a:shade val="50000"/>
+                </a:schemeClr>
+              </a:lnRef>
+              <a:fillRef idx="1">
+                <a:schemeClr val="accent1"/>
+              </a:fillRef>
+              <a:effectRef idx="0">
+                <a:schemeClr val="accent1"/>
+              </a:effectRef>
+              <a:fontRef idx="minor">
+                <a:schemeClr val="lt1"/>
+              </a:fontRef>
+            </p:style>
+            <p:txBody>
+              <a:bodyPr rtlCol="0" anchor="ctr"/>
+              <a:lstStyle/>
+              <a:p>
+                <a:pPr algn="ctr"/>
+                <a:endParaRPr lang="en-IN"/>
+              </a:p>
+            </p:txBody>
+          </p:sp>
+          <p:sp>
+            <p:nvSpPr>
+              <p:cNvPr id="8" name="Rectangle 7"/>
+              <p:cNvSpPr/>
+              <p:nvPr/>
+            </p:nvSpPr>
+            <p:spPr>
+              <a:xfrm>
+                <a:off x="7874000" y="482600"/>
+                <a:ext cx="901700" cy="2806700"/>
+              </a:xfrm>
+              <a:prstGeom prst="rect">
+                <a:avLst/>
+              </a:prstGeom>
+              <a:solidFill>
+                <a:schemeClr val="accent6">
+                  <a:lumMod val="50000"/>
+                </a:schemeClr>
+              </a:solidFill>
+              <a:ln>
+                <a:noFill/>
+              </a:ln>
+            </p:spPr>
+            <p:style>
+              <a:lnRef idx="2">
+                <a:schemeClr val="accent1">
+                  <a:shade val="50000"/>
+                </a:schemeClr>
+              </a:lnRef>
+              <a:fillRef idx="1">
+                <a:schemeClr val="accent1"/>
+              </a:fillRef>
+              <a:effectRef idx="0">
+                <a:schemeClr val="accent1"/>
+              </a:effectRef>
+              <a:fontRef idx="minor">
+                <a:schemeClr val="lt1"/>
+              </a:fontRef>
+            </p:style>
+            <p:txBody>
+              <a:bodyPr rtlCol="0" anchor="ctr"/>
+              <a:lstStyle/>
+              <a:p>
+                <a:pPr algn="ctr"/>
+                <a:endParaRPr lang="en-IN"/>
+              </a:p>
+            </p:txBody>
+          </p:sp>
+          <p:sp>
+            <p:nvSpPr>
+              <p:cNvPr id="10" name="Rectangle 9"/>
+              <p:cNvSpPr/>
+              <p:nvPr/>
+            </p:nvSpPr>
+            <p:spPr>
+              <a:xfrm>
+                <a:off x="3365500" y="482600"/>
+                <a:ext cx="901700" cy="2806700"/>
+              </a:xfrm>
+              <a:prstGeom prst="rect">
+                <a:avLst/>
+              </a:prstGeom>
+              <a:solidFill>
+                <a:srgbClr val="91C46E"/>
+              </a:solidFill>
+              <a:ln>
+                <a:noFill/>
+              </a:ln>
+            </p:spPr>
+            <p:style>
+              <a:lnRef idx="2">
+                <a:schemeClr val="accent1">
+                  <a:shade val="50000"/>
+                </a:schemeClr>
+              </a:lnRef>
+              <a:fillRef idx="1">
+                <a:schemeClr val="accent1"/>
+              </a:fillRef>
+              <a:effectRef idx="0">
+                <a:schemeClr val="accent1"/>
+              </a:effectRef>
+              <a:fontRef idx="minor">
+                <a:schemeClr val="lt1"/>
+              </a:fontRef>
+            </p:style>
+            <p:txBody>
+              <a:bodyPr rtlCol="0" anchor="ctr"/>
+              <a:lstStyle/>
+              <a:p>
+                <a:pPr algn="ctr"/>
+                <a:endParaRPr lang="en-IN"/>
+              </a:p>
+            </p:txBody>
+          </p:sp>
+          <p:sp>
+            <p:nvSpPr>
+              <p:cNvPr id="11" name="Rectangle 10"/>
+              <p:cNvSpPr/>
+              <p:nvPr/>
+            </p:nvSpPr>
+            <p:spPr>
+              <a:xfrm>
+                <a:off x="5168900" y="482600"/>
+                <a:ext cx="901700" cy="2806700"/>
+              </a:xfrm>
+              <a:prstGeom prst="rect">
+                <a:avLst/>
+              </a:prstGeom>
+              <a:solidFill>
+                <a:srgbClr val="7CB953"/>
+              </a:solidFill>
+              <a:ln>
+                <a:noFill/>
+              </a:ln>
+            </p:spPr>
+            <p:style>
+              <a:lnRef idx="2">
+                <a:schemeClr val="accent1">
+                  <a:shade val="50000"/>
+                </a:schemeClr>
+              </a:lnRef>
+              <a:fillRef idx="1">
+                <a:schemeClr val="accent1"/>
+              </a:fillRef>
+              <a:effectRef idx="0">
+                <a:schemeClr val="accent1"/>
+              </a:effectRef>
+              <a:fontRef idx="minor">
+                <a:schemeClr val="lt1"/>
+              </a:fontRef>
+            </p:style>
+            <p:txBody>
+              <a:bodyPr rtlCol="0" anchor="ctr"/>
+              <a:lstStyle/>
+              <a:p>
+                <a:pPr algn="ctr"/>
+                <a:endParaRPr lang="en-IN"/>
+              </a:p>
+            </p:txBody>
+          </p:sp>
+        </p:grpSp>
+        <p:sp>
+          <p:nvSpPr>
+            <p:cNvPr id="13" name="TextBox 12"/>
+            <p:cNvSpPr txBox="1"/>
+            <p:nvPr/>
+          </p:nvSpPr>
+          <p:spPr>
+            <a:xfrm>
+              <a:off x="807364" y="3289300"/>
+              <a:ext cx="7821372" cy="461665"/>
+            </a:xfrm>
+            <a:prstGeom prst="rect">
+              <a:avLst/>
+            </a:prstGeom>
+            <a:noFill/>
+          </p:spPr>
+          <p:txBody>
+            <a:bodyPr wrap="none" rtlCol="0">
+              <a:spAutoFit/>
+            </a:bodyPr>
+            <a:lstStyle/>
+            <a:p>
+              <a:r>
+                <a:rPr lang="en-US" sz="2400" dirty="0" smtClean="0">
+                  <a:latin typeface="Arial Rounded MT Bold" panose="020F0704030504030204" pitchFamily="34" charset="0"/>
+                </a:rPr>
+                <a:t>A1      A2       A3 </a:t>
+              </a:r>
+              <a:r>
+                <a:rPr lang="en-US" sz="2400" dirty="0">
+                  <a:latin typeface="Arial Rounded MT Bold" panose="020F0704030504030204" pitchFamily="34" charset="0"/>
+                </a:rPr>
+                <a:t> </a:t>
+              </a:r>
+              <a:r>
+                <a:rPr lang="en-US" sz="2400" dirty="0" smtClean="0">
+                  <a:latin typeface="Arial Rounded MT Bold" panose="020F0704030504030204" pitchFamily="34" charset="0"/>
+                </a:rPr>
+                <a:t>    A4 </a:t>
+              </a:r>
+              <a:r>
+                <a:rPr lang="en-US" sz="2400" dirty="0">
+                  <a:latin typeface="Arial Rounded MT Bold" panose="020F0704030504030204" pitchFamily="34" charset="0"/>
+                </a:rPr>
+                <a:t> </a:t>
+              </a:r>
+              <a:r>
+                <a:rPr lang="en-US" sz="2400" dirty="0" smtClean="0">
+                  <a:latin typeface="Arial Rounded MT Bold" panose="020F0704030504030204" pitchFamily="34" charset="0"/>
+                </a:rPr>
+                <a:t>     A5 </a:t>
+              </a:r>
+              <a:r>
+                <a:rPr lang="en-US" sz="2400" dirty="0">
+                  <a:latin typeface="Arial Rounded MT Bold" panose="020F0704030504030204" pitchFamily="34" charset="0"/>
+                </a:rPr>
+                <a:t> </a:t>
+              </a:r>
+              <a:r>
+                <a:rPr lang="en-US" sz="2400" dirty="0" smtClean="0">
+                  <a:latin typeface="Arial Rounded MT Bold" panose="020F0704030504030204" pitchFamily="34" charset="0"/>
+                </a:rPr>
+                <a:t>    A6 </a:t>
+              </a:r>
+              <a:r>
+                <a:rPr lang="en-US" sz="2400" dirty="0">
+                  <a:latin typeface="Arial Rounded MT Bold" panose="020F0704030504030204" pitchFamily="34" charset="0"/>
+                </a:rPr>
+                <a:t> </a:t>
+              </a:r>
+              <a:r>
+                <a:rPr lang="en-US" sz="2400" dirty="0" smtClean="0">
+                  <a:latin typeface="Arial Rounded MT Bold" panose="020F0704030504030204" pitchFamily="34" charset="0"/>
+                </a:rPr>
+                <a:t>     A7 </a:t>
+              </a:r>
+              <a:r>
+                <a:rPr lang="en-US" sz="2400" dirty="0">
+                  <a:latin typeface="Arial Rounded MT Bold" panose="020F0704030504030204" pitchFamily="34" charset="0"/>
+                </a:rPr>
+                <a:t> </a:t>
+              </a:r>
+              <a:r>
+                <a:rPr lang="en-US" sz="2400" dirty="0" smtClean="0">
+                  <a:latin typeface="Arial Rounded MT Bold" panose="020F0704030504030204" pitchFamily="34" charset="0"/>
+                </a:rPr>
+                <a:t>    A8 </a:t>
+              </a:r>
+              <a:r>
+                <a:rPr lang="en-US" sz="2400" dirty="0">
+                  <a:latin typeface="Arial Rounded MT Bold" panose="020F0704030504030204" pitchFamily="34" charset="0"/>
+                </a:rPr>
+                <a:t> </a:t>
+              </a:r>
+              <a:r>
+                <a:rPr lang="en-US" sz="2400" dirty="0" smtClean="0">
+                  <a:latin typeface="Arial Rounded MT Bold" panose="020F0704030504030204" pitchFamily="34" charset="0"/>
+                </a:rPr>
+                <a:t>     A9</a:t>
+              </a:r>
+              <a:endParaRPr lang="en-IN" sz="2400" dirty="0">
+                <a:latin typeface="Arial Rounded MT Bold" panose="020F0704030504030204" pitchFamily="34" charset="0"/>
+              </a:endParaRPr>
+            </a:p>
+          </p:txBody>
+        </p:sp>
+      </p:grpSp>
+    </p:spTree>
+    <p:extLst>
+      <p:ext uri="{BB962C8B-B14F-4D97-AF65-F5344CB8AC3E}">
+        <p14:creationId xmlns:p14="http://schemas.microsoft.com/office/powerpoint/2010/main" val="586146957"/>
+      </p:ext>
+    </p:extLst>
+  </p:cSld>
+  <p:clrMapOvr>
+    <a:masterClrMapping/>
+  </p:clrMapOvr>
+</p:sld>
+</file>
+
 <file path=ppt/theme/theme1.xml><?xml version="1.0" encoding="utf-8"?>
 <a:theme xmlns:a="http://schemas.openxmlformats.org/drawingml/2006/main" name="Office Theme">
   <a:themeElements>

</xml_diff>